<commit_message>
Call-out notice standardized to at least 2-4 hours (packet, flow, deck)
Co-Authored-By: Claude Opus 5.5 <noreply@anthropic.com>
Claude-Session: https://claude.ai/code/session_01HLo3JnRak3uKKzJxV1Vq3d
</commit_message>
<xml_diff>
--- a/nhe-trainer-deck.pptx
+++ b/nhe-trainer-deck.pptx
@@ -3439,7 +3439,7 @@
           <a:p>
             <a:r>
               <a:rPr lang="en-US" dirty="0"/>
-              <a:t>CHECK-IN (5 min, at the start of Module 2). 1. Call-out: have them recite it back to you: call AND text your supervisor and the on-call manager, at least 2 hours ahead, reason and expected return. "If you skip the procedure, the absence is unexcused, whatever the reason." Three unexcused absences in 90 days triggers review. No call, no show = treated as resignation. 2. Swap: "This is the step that gets skipped most. Two agents agree, nobody tells management, one doesn't show. Now the site is uncovered and two agents have a problem." 3. Authorization: "A leasing agent you don't recognize says the PM approved unit access. What do you do?" Answer: verify independently with your supervisor or PM, then log who asked, who you verified with, and the time. Remind them the paper acknowledgment form gets signed before the coach block.</a:t>
+              <a:t>CHECK-IN (5 min, at the start of Module 2). 1. Call-out: have them recite it back to you: call AND text your supervisor and the on-call manager, at least 2–4 hours ahead, reason and expected return. "If you skip the procedure, the absence is unexcused, whatever the reason." Three unexcused absences in 90 days triggers review. No call, no show = treated as resignation. 2. Swap: "This is the step that gets skipped most. Two agents agree, nobody tells management, one doesn't show. Now the site is uncovered and two agents have a problem." 3. Authorization: "A leasing agent you don't recognize says the PM approved unit access. What do you do?" Answer: verify independently with your supervisor or PM, then log who asked, who you verified with, and the time. Remind them the paper acknowledgment form gets signed before the coach block.</a:t>
             </a:r>
             <a:endParaRPr lang="en-US" dirty="0"/>
           </a:p>
@@ -22840,7 +22840,7 @@
                 <a:ea typeface="Arial" pitchFamily="34" charset="-122"/>
                 <a:cs typeface="Arial" pitchFamily="34" charset="-120"/>
               </a:rPr>
-              <a:t> at least 2 hours before your shift. One without the other is unexcused.</a:t>
+              <a:t> at least 2–4 hours before your shift. One without the other is unexcused.</a:t>
             </a:r>
             <a:endParaRPr lang="en-US" sz="1600" dirty="0"/>
           </a:p>

</xml_diff>

<commit_message>
Set package, call-out rules; fix legacy bugs
Package rules (set 10/8/2026) across packet, flow, deck, SOP library, refreshers,
scorecard, coaching guide and legacy NHO pages:
- Receive -> Label -> Log (system + package intake sheet) -> Store -> Notify
- Release: system lookup every time, photo ID not required; read the label and
  confirm name/unit match the record before handover
- Food delivery: call first, refrigerate if no answer
- Package "pending approval" flags removed
Call-out notice: at least 2-4 hours everywhere (policy hub, legacy pages).
Conduct acknowledgment PDF rebuilt: no name byline, new package line.
Bugs: co-facilitator missing updateTopbarNextButton (broke every page turn);
materials library and NHO outline sideways scroll on phones/desktop.

Co-Authored-By: Claude Opus 5.5 <noreply@anthropic.com>
Claude-Session: https://claude.ai/code/session_017gauyUCyE5mT6nEHmaxMQK
</commit_message>
<xml_diff>
--- a/nhe-trainer-deck.pptx
+++ b/nhe-trainer-deck.pptx
@@ -887,7 +887,7 @@
           <a:p>
             <a:r>
               <a:rPr lang="en-US" dirty="0"/>
-              <a:t>CHECK-IN (5 min, right after the meal break). Energy dips here; keep it brisk and ask questions instead of lecturing. 1. Perishables: "DoorDash for 1210, no answer. What do you do?" (Log, refrigerate, CALL not text, 24 hours.) "Instacart?" (Daily outreach, escalate to Lead before disposal at 48.) 2. Language: use the elevator example. "The resident reported that an elevator door closed on her leg" is a fact you can stand on. "The elevator closed on her leg" is a conclusion you didn't witness. Never give medication, diagnose, or judge severity. 3. Call first: "You call, you clear, you document. That's the job." Critical incidents (safety, legal, police): phone the Regional Manager immediately, then file in Connecteam before end of shift. Tell them the emergency drill in the coach block is from memory, no notes.</a:t>
+              <a:t>CHECK-IN (5 min, right after the meal break). Energy dips here; keep it brisk and ask questions instead of lecturing. 1. Perishables: "DoorDash for 1210, no answer. What do you do?" (Label, log, CALL not text, refrigerate if no answer in 15–30 minutes, 24 hours.) "Instacart?" (Daily outreach, escalate to Lead before disposal at 48.) 2. Language: use the elevator example. "The resident reported that an elevator door closed on her leg" is a fact you can stand on. "The elevator closed on her leg" is a conclusion you didn't witness. Never give medication, diagnose, or judge severity. 3. Call first: "You call, you clear, you document. That's the job." Critical incidents (safety, legal, police): phone the Regional Manager immediately, then file in Connecteam before end of shift. Tell them the emergency drill in the coach block is from memory, no notes.</a:t>
             </a:r>
             <a:endParaRPr lang="en-US" dirty="0"/>
           </a:p>
@@ -975,7 +975,7 @@
           <a:p>
             <a:r>
               <a:rPr lang="en-US" dirty="0"/>
-              <a:t>Ask: "Why does logging come before storage, not after?" The answer is chain of custody. "If a package disappears between intake and the shelf and there's no entry, there's no record it was ever received." Then release: "Verify identity before you retrieve the package, every time, however well you know them. If anything doesn't match, hold it and call your Lead. Never release under pressure." High-value (laptops, electronics, luxury goods) never goes on the general shelf. No postage, no outgoing acceptance. ANS hires: paper log with unit, initials and carrier, and missing packages go to Connecteam, not the shift log. Their site page in the packet covers it.</a:t>
+              <a:t>Ask: "Why does logging (system and intake sheet) come before storage, not after?" The answer is chain of custody. "If a package disappears between intake and the shelf and there's no entry, there's no record it was ever received." Then release: "Run a system lookup on the resident before you retrieve the package, every time, however well you know them. Photo ID isn't required. Before handover, read the label and confirm the name and unit match the system record. If anything doesn't match, hold it and call your Lead. Never release under pressure." High-value (laptops, electronics, luxury goods) never goes on the general shelf. No postage, no outgoing acceptance. ANS hires: paper log with unit, initials and carrier, and missing packages go to Connecteam, not the shift log. Their site page in the packet covers it.</a:t>
             </a:r>
             <a:endParaRPr lang="en-US" dirty="0"/>
           </a:p>
@@ -5608,7 +5608,7 @@
                 <a:ea typeface="Arial" pitchFamily="34" charset="-122"/>
                 <a:cs typeface="Arial" pitchFamily="34" charset="-120"/>
               </a:rPr>
-              <a:t>Four intake steps</a:t>
+              <a:t>Five intake steps</a:t>
             </a:r>
             <a:endParaRPr lang="en-US" sz="1400" dirty="0"/>
           </a:p>
@@ -5785,6 +5785,10 @@
             <a:prstDash val="solid"/>
           </a:ln>
         </p:spPr>
+        <p:txBody>
+          <a:bodyPr/>
+          <a:p/>
+        </p:txBody>
       </p:sp>
       <p:sp>
         <p:nvSpPr>
@@ -5907,6 +5911,10 @@
             <a:prstDash val="solid"/>
           </a:ln>
         </p:spPr>
+        <p:txBody>
+          <a:bodyPr/>
+          <a:p/>
+        </p:txBody>
       </p:sp>
       <p:sp>
         <p:nvSpPr>
@@ -6029,6 +6037,10 @@
             <a:prstDash val="solid"/>
           </a:ln>
         </p:spPr>
+        <p:txBody>
+          <a:bodyPr/>
+          <a:p/>
+        </p:txBody>
       </p:sp>
       <p:sp>
         <p:nvSpPr>
@@ -6052,6 +6064,10 @@
             <a:prstDash val="solid"/>
           </a:ln>
         </p:spPr>
+        <p:txBody>
+          <a:bodyPr/>
+          <a:p/>
+        </p:txBody>
       </p:sp>
       <p:sp>
         <p:nvSpPr>
@@ -6312,7 +6328,7 @@
                 <a:ea typeface="Georgia" pitchFamily="18" charset="-122"/>
                 <a:cs typeface="Georgia" pitchFamily="18" charset="-120"/>
               </a:rPr>
-              <a:t>Log it before you </a:t>
+              <a:t>Log it before </a:t>
             </a:r>
             <a:r>
               <a:rPr lang="en-US" sz="6000" b="1" i="1" dirty="0">
@@ -6323,7 +6339,7 @@
                 <a:ea typeface="Georgia" pitchFamily="18" charset="-122"/>
                 <a:cs typeface="Georgia" pitchFamily="18" charset="-120"/>
               </a:rPr>
-              <a:t>move it.</a:t>
+              <a:t>it goes to storage.</a:t>
             </a:r>
             <a:endParaRPr lang="en-US" sz="6000" dirty="0"/>
           </a:p>
@@ -6367,7 +6383,7 @@
                 <a:ea typeface="Arial" pitchFamily="34" charset="-122"/>
                 <a:cs typeface="Arial" pitchFamily="34" charset="-120"/>
               </a:rPr>
-              <a:t>Confirm, log, label, notify. Every package, every time.</a:t>
+              <a:t>Receive, label, log, store, notify. Every package, every time.</a:t>
             </a:r>
             <a:endParaRPr lang="en-US" sz="1800" dirty="0"/>
           </a:p>

</xml_diff>